<commit_message>
build: 「FDP가 뭐야?」 영상 30 → 50초 · WAF "와프" 발음 · 덱 버튼 50초 (영상 v1.1, 덱 v5.2, dashboard v2.49.17)
- 내레이션 11개 대사, 속도 +10%, 길이 = 마지막 대사 + 여운(cues.js DURATION 50.0)
- 화면 전개 약 0.6배 속도, 타이틀 · 배치 힌트 분리, 결과 10초(−97% 강조 → 맺음말), 자막 WAF(와프)
- 대시보드 영상 카드 50초 · 장 7개, 덱 3장 버튼 「▶ 50초 영상 · FDP 원리」

Co-Authored-By: Claude Opus 5.5 <noreply@anthropic.com>
Claude-Session: https://claude.ai/code/session_01RcgHo7d4fnsv4zuWqV4CUZ
</commit_message>
<xml_diff>
--- a/dashboard/public/presentations/ssd-future-ready-strategy.pptx
+++ b/dashboard/public/presentations/ssd-future-ready-strategy.pptx
@@ -649,7 +649,7 @@
           <a:lstStyle/>
           <a:p>
             <a:r>
-              <a:t>3장은 SSD 차별화 요구의 변화와, 그에 대비한 포트폴리오입니다. 맨 위 띠처럼 SSD의 차별화 요구는 성능, 전력 효율, VM 단위 QoS를 거쳐, AI 시대에는 예측 가능한 QoS, 고용량, 고내구로 바뀌고 있습니다. 세 기술이 겨냥하는 것은 QLC 고용량과 고객 워크로드에 맞춘 내구성입니다. 시기 구분은 과제팀 정리입니다. 1번은 원리입니다. GC가 일어나면 읽기가 기다려 지연 스파이크가 생깁니다. Mixed Media는 GC 빈도를, Large Mapping은 GC 횟수를, FDP는 GC 시간을 줄입니다. GC가 드물고 짧아지면 지연이 예측 가능해집니다. FDP의 원리는 오른쪽 위 30초 영상 버튼으로 바로 보여 드릴 수 있습니다. 2번은 결과입니다. Meta CacheLib에 FDP를 적용하자 WAF가 3.22에서 1.03으로 68퍼센트, PM9D3a RocksDB에서 p99.9 꼬리 지연이 55퍼센트 줄었습니다. WAF가 SSD만으로 3 근처에 머문 이유는 참고 5장에 있고, 상자를 누르면 그 장으로 갑니다. 꼬리 지연 측정은 TLC 결과라는 한계가 있습니다. 3번은 포트폴리오입니다. 바닥은 정격 DWPD와 용량, 높이는 꼬리 지연입니다. WAF가 3에서 1이 되면 정격 DWPD는 약 3배가 됩니다. 과제팀 산술입니다. [클릭] 네 제품군이 한꺼번에 넓어집니다. QLC는 0.3에서 1 DWPD로 TLC가 맡던 KV 오프로드까지, 고성능 TLC는 1에서 3으로 쓰기 많은 KV까지, 고내구 TLC는 3에서 9로 초고DWPD 입구까지, SLC급은 30에서 100 근처까지 갑니다. 초고DWPD 요구가 오면 TLC와 SLC급 가운데 고를 수 있습니다. 대비한 기술이 있어야 미래 수요에 능동적으로 대응하는 포트폴리오를 완성할 수 있습니다.</a:t>
+              <a:t>3장은 SSD 차별화 요구의 변화와, 그에 대비한 포트폴리오입니다. 맨 위 띠처럼 SSD의 차별화 요구는 성능, 전력 효율, VM 단위 QoS를 거쳐, AI 시대에는 예측 가능한 QoS, 고용량, 고내구로 바뀌고 있습니다. 세 기술이 겨냥하는 것은 QLC 고용량과 고객 워크로드에 맞춘 내구성입니다. 시기 구분은 과제팀 정리입니다. 1번은 원리입니다. GC가 일어나면 읽기가 기다려 지연 스파이크가 생깁니다. Mixed Media는 GC 빈도를, Large Mapping은 GC 횟수를, FDP는 GC 시간을 줄입니다. GC가 드물고 짧아지면 지연이 예측 가능해집니다. FDP의 원리는 오른쪽 위 50초 영상 버튼으로 바로 보여 드릴 수 있습니다. 2번은 결과입니다. Meta CacheLib에 FDP를 적용하자 WAF가 3.22에서 1.03으로 68퍼센트, PM9D3a RocksDB에서 p99.9 꼬리 지연이 55퍼센트 줄었습니다. WAF가 SSD만으로 3 근처에 머문 이유는 참고 5장에 있고, 상자를 누르면 그 장으로 갑니다. 꼬리 지연 측정은 TLC 결과라는 한계가 있습니다. 3번은 포트폴리오입니다. 바닥은 정격 DWPD와 용량, 높이는 꼬리 지연입니다. WAF가 3에서 1이 되면 정격 DWPD는 약 3배가 됩니다. 과제팀 산술입니다. [클릭] 네 제품군이 한꺼번에 넓어집니다. QLC는 0.3에서 1 DWPD로 TLC가 맡던 KV 오프로드까지, 고성능 TLC는 1에서 3으로 쓰기 많은 KV까지, 고내구 TLC는 3에서 9로 초고DWPD 입구까지, SLC급은 30에서 100 근처까지 갑니다. 초고DWPD 요구가 오면 TLC와 SLC급 가운데 고를 수 있습니다. 대비한 기술이 있어야 미래 수요에 능동적으로 대응하는 포트폴리오를 완성할 수 있습니다.</a:t>
             </a:r>
           </a:p>
         </p:txBody>
@@ -28956,7 +28956,7 @@
                 <a:latin typeface="Arial"/>
                 <a:ea typeface="Arial"/>
               </a:rPr>
-              <a:t>▶  30초 영상 · FDP 원리</a:t>
+              <a:t>▶  50초 영상 · FDP 원리</a:t>
             </a:r>
           </a:p>
         </p:txBody>

</xml_diff>

<commit_message>
build: 「FDP가 뭐야?」 영상 1분(58초) — WAF 정의 · DWPD 개념 추가 · 덱 버튼 「1분 영상」 (영상 v1.2, 덱 v5.3, dashboard v2.49.18)
- 내레이션: WAF = 낸드에 쓴 양 ÷ 호스트가 쓴 양, DWPD 대사(하루에 전체 용량을 몇 번 · 약 3배)
- 화면: WAF 수식 강조, 결과 장면 DWPD 정의 + 상대 DWPD 막대(WAF 비), 감소율은 막대 옆
- 대시보드 카드 1분 · 장 9개, 덱 3장 버튼 「▶ 1분 영상 · FDP 원리」

Co-Authored-By: Claude Opus 5.5 <noreply@anthropic.com>
Claude-Session: https://claude.ai/code/session_01RcgHo7d4fnsv4zuWqV4CUZ
</commit_message>
<xml_diff>
--- a/dashboard/public/presentations/ssd-future-ready-strategy.pptx
+++ b/dashboard/public/presentations/ssd-future-ready-strategy.pptx
@@ -649,7 +649,7 @@
           <a:lstStyle/>
           <a:p>
             <a:r>
-              <a:t>3장은 SSD 차별화 요구의 변화와, 그에 대비한 포트폴리오입니다. 맨 위 띠처럼 SSD의 차별화 요구는 성능, 전력 효율, VM 단위 QoS를 거쳐, AI 시대에는 예측 가능한 QoS, 고용량, 고내구로 바뀌고 있습니다. 세 기술이 겨냥하는 것은 QLC 고용량과 고객 워크로드에 맞춘 내구성입니다. 시기 구분은 과제팀 정리입니다. 1번은 원리입니다. GC가 일어나면 읽기가 기다려 지연 스파이크가 생깁니다. Mixed Media는 GC 빈도를, Large Mapping은 GC 횟수를, FDP는 GC 시간을 줄입니다. GC가 드물고 짧아지면 지연이 예측 가능해집니다. FDP의 원리는 오른쪽 위 50초 영상 버튼으로 바로 보여 드릴 수 있습니다. 2번은 결과입니다. Meta CacheLib에 FDP를 적용하자 WAF가 3.22에서 1.03으로 68퍼센트, PM9D3a RocksDB에서 p99.9 꼬리 지연이 55퍼센트 줄었습니다. WAF가 SSD만으로 3 근처에 머문 이유는 참고 5장에 있고, 상자를 누르면 그 장으로 갑니다. 꼬리 지연 측정은 TLC 결과라는 한계가 있습니다. 3번은 포트폴리오입니다. 바닥은 정격 DWPD와 용량, 높이는 꼬리 지연입니다. WAF가 3에서 1이 되면 정격 DWPD는 약 3배가 됩니다. 과제팀 산술입니다. [클릭] 네 제품군이 한꺼번에 넓어집니다. QLC는 0.3에서 1 DWPD로 TLC가 맡던 KV 오프로드까지, 고성능 TLC는 1에서 3으로 쓰기 많은 KV까지, 고내구 TLC는 3에서 9로 초고DWPD 입구까지, SLC급은 30에서 100 근처까지 갑니다. 초고DWPD 요구가 오면 TLC와 SLC급 가운데 고를 수 있습니다. 대비한 기술이 있어야 미래 수요에 능동적으로 대응하는 포트폴리오를 완성할 수 있습니다.</a:t>
+              <a:t>3장은 SSD 차별화 요구의 변화와, 그에 대비한 포트폴리오입니다. 맨 위 띠처럼 SSD의 차별화 요구는 성능, 전력 효율, VM 단위 QoS를 거쳐, AI 시대에는 예측 가능한 QoS, 고용량, 고내구로 바뀌고 있습니다. 세 기술이 겨냥하는 것은 QLC 고용량과 고객 워크로드에 맞춘 내구성입니다. 시기 구분은 과제팀 정리입니다. 1번은 원리입니다. GC가 일어나면 읽기가 기다려 지연 스파이크가 생깁니다. Mixed Media는 GC 빈도를, Large Mapping은 GC 횟수를, FDP는 GC 시간을 줄입니다. GC가 드물고 짧아지면 지연이 예측 가능해집니다. FDP의 원리는 오른쪽 위 1분 영상 버튼으로 바로 보여 드릴 수 있습니다. 2번은 결과입니다. Meta CacheLib에 FDP를 적용하자 WAF가 3.22에서 1.03으로 68퍼센트, PM9D3a RocksDB에서 p99.9 꼬리 지연이 55퍼센트 줄었습니다. WAF가 SSD만으로 3 근처에 머문 이유는 참고 5장에 있고, 상자를 누르면 그 장으로 갑니다. 꼬리 지연 측정은 TLC 결과라는 한계가 있습니다. 3번은 포트폴리오입니다. 바닥은 정격 DWPD와 용량, 높이는 꼬리 지연입니다. WAF가 3에서 1이 되면 정격 DWPD는 약 3배가 됩니다. 과제팀 산술입니다. [클릭] 네 제품군이 한꺼번에 넓어집니다. QLC는 0.3에서 1 DWPD로 TLC가 맡던 KV 오프로드까지, 고성능 TLC는 1에서 3으로 쓰기 많은 KV까지, 고내구 TLC는 3에서 9로 초고DWPD 입구까지, SLC급은 30에서 100 근처까지 갑니다. 초고DWPD 요구가 오면 TLC와 SLC급 가운데 고를 수 있습니다. 대비한 기술이 있어야 미래 수요에 능동적으로 대응하는 포트폴리오를 완성할 수 있습니다.</a:t>
             </a:r>
           </a:p>
         </p:txBody>
@@ -28956,7 +28956,7 @@
                 <a:latin typeface="Arial"/>
                 <a:ea typeface="Arial"/>
               </a:rPr>
-              <a:t>▶  50초 영상 · FDP 원리</a:t>
+              <a:t>▶  1분 영상 · FDP 원리</a:t>
             </a:r>
           </a:p>
         </p:txBody>

</xml_diff>